<commit_message>
Modifica Elenco Puntato Slide 6
</commit_message>
<xml_diff>
--- a/docs/Sistema cargoservice_ Automazione Carico.pptx
+++ b/docs/Sistema cargoservice_ Automazione Carico.pptx
@@ -2369,8 +2369,8 @@
         </p:nvSpPr>
         <p:spPr>
           <a:xfrm>
-            <a:off x="1143225" y="685800"/>
-            <a:ext cx="4572225" cy="3429000"/>
+            <a:off x="381000" y="685800"/>
+            <a:ext cx="6096000" cy="3429000"/>
           </a:xfrm>
           <a:custGeom>
             <a:avLst/>
@@ -21172,7 +21172,7 @@
               <a:buNone/>
             </a:pPr>
             <a:r>
-              <a:rPr lang="en-US" sz="1800">
+              <a:rPr lang="en-US" sz="1800" dirty="0">
                 <a:solidFill>
                   <a:schemeClr val="lt1"/>
                 </a:solidFill>
@@ -21183,7 +21183,7 @@
               </a:rPr>
               <a:t>Raspberry Pi Pico W</a:t>
             </a:r>
-            <a:endParaRPr sz="1800">
+            <a:endParaRPr sz="1800" dirty="0">
               <a:solidFill>
                 <a:schemeClr val="lt1"/>
               </a:solidFill>
@@ -21207,7 +21207,7 @@
               <a:buFont typeface="Arial"/>
               <a:buNone/>
             </a:pPr>
-            <a:endParaRPr sz="1800">
+            <a:endParaRPr sz="1800" dirty="0">
               <a:solidFill>
                 <a:srgbClr val="F8FAFC"/>
               </a:solidFill>
@@ -21235,7 +21235,7 @@
               <a:buNone/>
             </a:pPr>
             <a:r>
-              <a:rPr lang="en-US" sz="1200">
+              <a:rPr lang="en-US" sz="1200" dirty="0">
                 <a:solidFill>
                   <a:srgbClr val="94A3B8"/>
                 </a:solidFill>
@@ -21244,9 +21244,249 @@
                 <a:cs typeface="Inter"/>
                 <a:sym typeface="Inter"/>
               </a:rPr>
-              <a:t>Il passaggio dall'emulatore software all'hardware fisico reale è avvenuto a caldo, senza modificare l'orchestratore, grazie all'interfaccia standardizzata MQTT.</a:t>
-            </a:r>
-            <a:endParaRPr>
+              <a:t>Il passaggio </a:t>
+            </a:r>
+            <a:r>
+              <a:rPr lang="en-US" sz="1200" dirty="0" err="1">
+                <a:solidFill>
+                  <a:srgbClr val="94A3B8"/>
+                </a:solidFill>
+                <a:latin typeface="Inter"/>
+                <a:ea typeface="Inter"/>
+                <a:cs typeface="Inter"/>
+                <a:sym typeface="Inter"/>
+              </a:rPr>
+              <a:t>dall'emulatore</a:t>
+            </a:r>
+            <a:r>
+              <a:rPr lang="en-US" sz="1200" dirty="0">
+                <a:solidFill>
+                  <a:srgbClr val="94A3B8"/>
+                </a:solidFill>
+                <a:latin typeface="Inter"/>
+                <a:ea typeface="Inter"/>
+                <a:cs typeface="Inter"/>
+                <a:sym typeface="Inter"/>
+              </a:rPr>
+              <a:t> software </a:t>
+            </a:r>
+            <a:r>
+              <a:rPr lang="en-US" sz="1200" dirty="0" err="1">
+                <a:solidFill>
+                  <a:srgbClr val="94A3B8"/>
+                </a:solidFill>
+                <a:latin typeface="Inter"/>
+                <a:ea typeface="Inter"/>
+                <a:cs typeface="Inter"/>
+                <a:sym typeface="Inter"/>
+              </a:rPr>
+              <a:t>all'hardware</a:t>
+            </a:r>
+            <a:r>
+              <a:rPr lang="en-US" sz="1200" dirty="0">
+                <a:solidFill>
+                  <a:srgbClr val="94A3B8"/>
+                </a:solidFill>
+                <a:latin typeface="Inter"/>
+                <a:ea typeface="Inter"/>
+                <a:cs typeface="Inter"/>
+                <a:sym typeface="Inter"/>
+              </a:rPr>
+              <a:t> </a:t>
+            </a:r>
+            <a:r>
+              <a:rPr lang="en-US" sz="1200" dirty="0" err="1">
+                <a:solidFill>
+                  <a:srgbClr val="94A3B8"/>
+                </a:solidFill>
+                <a:latin typeface="Inter"/>
+                <a:ea typeface="Inter"/>
+                <a:cs typeface="Inter"/>
+                <a:sym typeface="Inter"/>
+              </a:rPr>
+              <a:t>fisico</a:t>
+            </a:r>
+            <a:r>
+              <a:rPr lang="en-US" sz="1200" dirty="0">
+                <a:solidFill>
+                  <a:srgbClr val="94A3B8"/>
+                </a:solidFill>
+                <a:latin typeface="Inter"/>
+                <a:ea typeface="Inter"/>
+                <a:cs typeface="Inter"/>
+                <a:sym typeface="Inter"/>
+              </a:rPr>
+              <a:t> </a:t>
+            </a:r>
+            <a:r>
+              <a:rPr lang="en-US" sz="1200" dirty="0" err="1">
+                <a:solidFill>
+                  <a:srgbClr val="94A3B8"/>
+                </a:solidFill>
+                <a:latin typeface="Inter"/>
+                <a:ea typeface="Inter"/>
+                <a:cs typeface="Inter"/>
+                <a:sym typeface="Inter"/>
+              </a:rPr>
+              <a:t>reale</a:t>
+            </a:r>
+            <a:r>
+              <a:rPr lang="en-US" sz="1200" dirty="0">
+                <a:solidFill>
+                  <a:srgbClr val="94A3B8"/>
+                </a:solidFill>
+                <a:latin typeface="Inter"/>
+                <a:ea typeface="Inter"/>
+                <a:cs typeface="Inter"/>
+                <a:sym typeface="Inter"/>
+              </a:rPr>
+              <a:t> è </a:t>
+            </a:r>
+            <a:r>
+              <a:rPr lang="en-US" sz="1200" dirty="0" err="1">
+                <a:solidFill>
+                  <a:srgbClr val="94A3B8"/>
+                </a:solidFill>
+                <a:latin typeface="Inter"/>
+                <a:ea typeface="Inter"/>
+                <a:cs typeface="Inter"/>
+                <a:sym typeface="Inter"/>
+              </a:rPr>
+              <a:t>avvenuto</a:t>
+            </a:r>
+            <a:r>
+              <a:rPr lang="en-US" sz="1200" dirty="0">
+                <a:solidFill>
+                  <a:srgbClr val="94A3B8"/>
+                </a:solidFill>
+                <a:latin typeface="Inter"/>
+                <a:ea typeface="Inter"/>
+                <a:cs typeface="Inter"/>
+                <a:sym typeface="Inter"/>
+              </a:rPr>
+              <a:t> a caldo, senza </a:t>
+            </a:r>
+            <a:r>
+              <a:rPr lang="en-US" sz="1200" dirty="0" err="1">
+                <a:solidFill>
+                  <a:srgbClr val="94A3B8"/>
+                </a:solidFill>
+                <a:latin typeface="Inter"/>
+                <a:ea typeface="Inter"/>
+                <a:cs typeface="Inter"/>
+                <a:sym typeface="Inter"/>
+              </a:rPr>
+              <a:t>modificare</a:t>
+            </a:r>
+            <a:r>
+              <a:rPr lang="en-US" sz="1200" dirty="0">
+                <a:solidFill>
+                  <a:srgbClr val="94A3B8"/>
+                </a:solidFill>
+                <a:latin typeface="Inter"/>
+                <a:ea typeface="Inter"/>
+                <a:cs typeface="Inter"/>
+                <a:sym typeface="Inter"/>
+              </a:rPr>
+              <a:t> </a:t>
+            </a:r>
+            <a:r>
+              <a:rPr lang="en-US" sz="1200" dirty="0" err="1">
+                <a:solidFill>
+                  <a:srgbClr val="94A3B8"/>
+                </a:solidFill>
+                <a:latin typeface="Inter"/>
+                <a:ea typeface="Inter"/>
+                <a:cs typeface="Inter"/>
+                <a:sym typeface="Inter"/>
+              </a:rPr>
+              <a:t>l'orchestratore</a:t>
+            </a:r>
+            <a:r>
+              <a:rPr lang="en-US" sz="1200" dirty="0">
+                <a:solidFill>
+                  <a:srgbClr val="94A3B8"/>
+                </a:solidFill>
+                <a:latin typeface="Inter"/>
+                <a:ea typeface="Inter"/>
+                <a:cs typeface="Inter"/>
+                <a:sym typeface="Inter"/>
+              </a:rPr>
+              <a:t>, </a:t>
+            </a:r>
+            <a:r>
+              <a:rPr lang="en-US" sz="1200" dirty="0" err="1">
+                <a:solidFill>
+                  <a:srgbClr val="94A3B8"/>
+                </a:solidFill>
+                <a:latin typeface="Inter"/>
+                <a:ea typeface="Inter"/>
+                <a:cs typeface="Inter"/>
+                <a:sym typeface="Inter"/>
+              </a:rPr>
+              <a:t>grazie</a:t>
+            </a:r>
+            <a:r>
+              <a:rPr lang="en-US" sz="1200" dirty="0">
+                <a:solidFill>
+                  <a:srgbClr val="94A3B8"/>
+                </a:solidFill>
+                <a:latin typeface="Inter"/>
+                <a:ea typeface="Inter"/>
+                <a:cs typeface="Inter"/>
+                <a:sym typeface="Inter"/>
+              </a:rPr>
+              <a:t> </a:t>
+            </a:r>
+            <a:r>
+              <a:rPr lang="en-US" sz="1200" dirty="0" err="1">
+                <a:solidFill>
+                  <a:srgbClr val="94A3B8"/>
+                </a:solidFill>
+                <a:latin typeface="Inter"/>
+                <a:ea typeface="Inter"/>
+                <a:cs typeface="Inter"/>
+                <a:sym typeface="Inter"/>
+              </a:rPr>
+              <a:t>all'interfaccia</a:t>
+            </a:r>
+            <a:r>
+              <a:rPr lang="en-US" sz="1200" dirty="0">
+                <a:solidFill>
+                  <a:srgbClr val="94A3B8"/>
+                </a:solidFill>
+                <a:latin typeface="Inter"/>
+                <a:ea typeface="Inter"/>
+                <a:cs typeface="Inter"/>
+                <a:sym typeface="Inter"/>
+              </a:rPr>
+              <a:t> </a:t>
+            </a:r>
+            <a:r>
+              <a:rPr lang="en-US" sz="1200" dirty="0" err="1">
+                <a:solidFill>
+                  <a:srgbClr val="94A3B8"/>
+                </a:solidFill>
+                <a:latin typeface="Inter"/>
+                <a:ea typeface="Inter"/>
+                <a:cs typeface="Inter"/>
+                <a:sym typeface="Inter"/>
+              </a:rPr>
+              <a:t>standardizzata</a:t>
+            </a:r>
+            <a:r>
+              <a:rPr lang="en-US" sz="1200" dirty="0">
+                <a:solidFill>
+                  <a:srgbClr val="94A3B8"/>
+                </a:solidFill>
+                <a:latin typeface="Inter"/>
+                <a:ea typeface="Inter"/>
+                <a:cs typeface="Inter"/>
+                <a:sym typeface="Inter"/>
+              </a:rPr>
+              <a:t> MQTT.</a:t>
+            </a:r>
+            <a:endParaRPr dirty="0">
               <a:solidFill>
                 <a:schemeClr val="dk1"/>
               </a:solidFill>
@@ -21266,7 +21506,7 @@
               <a:buFont typeface="Arial"/>
               <a:buNone/>
             </a:pPr>
-            <a:endParaRPr sz="1800">
+            <a:endParaRPr sz="1800" dirty="0">
               <a:solidFill>
                 <a:srgbClr val="F8FAFC"/>
               </a:solidFill>
@@ -21294,7 +21534,7 @@
               <a:buChar char="●"/>
             </a:pPr>
             <a:r>
-              <a:rPr lang="en-US" sz="1200">
+              <a:rPr lang="en-US" sz="1200" dirty="0">
                 <a:solidFill>
                   <a:srgbClr val="F8FAFC"/>
                 </a:solidFill>
@@ -21306,7 +21546,7 @@
               <a:t>Sonar HC-SR04:</a:t>
             </a:r>
             <a:r>
-              <a:rPr lang="en-US" sz="1200">
+              <a:rPr lang="en-US" sz="1200" dirty="0">
                 <a:solidFill>
                   <a:srgbClr val="94A3B8"/>
                 </a:solidFill>
@@ -21315,16 +21555,247 @@
                 <a:cs typeface="Inter"/>
                 <a:sym typeface="Inter"/>
               </a:rPr>
-              <a:t> Collegato via pin GPIO per rilevare l'ostacolo.</a:t>
-            </a:r>
-            <a:endParaRPr sz="1200">
+              <a:t> </a:t>
+            </a:r>
+            <a:r>
+              <a:rPr lang="en-US" sz="1200" dirty="0" err="1">
+                <a:solidFill>
+                  <a:srgbClr val="94A3B8"/>
+                </a:solidFill>
+                <a:latin typeface="Inter"/>
+                <a:ea typeface="Inter"/>
+                <a:cs typeface="Inter"/>
+                <a:sym typeface="Inter"/>
+              </a:rPr>
+              <a:t>Collegato</a:t>
+            </a:r>
+            <a:r>
+              <a:rPr lang="en-US" sz="1200" dirty="0">
+                <a:solidFill>
+                  <a:srgbClr val="94A3B8"/>
+                </a:solidFill>
+                <a:latin typeface="Inter"/>
+                <a:ea typeface="Inter"/>
+                <a:cs typeface="Inter"/>
+                <a:sym typeface="Inter"/>
+              </a:rPr>
+              <a:t> via pin GPIO per </a:t>
+            </a:r>
+            <a:r>
+              <a:rPr lang="en-US" sz="1200" dirty="0" err="1">
+                <a:solidFill>
+                  <a:srgbClr val="94A3B8"/>
+                </a:solidFill>
+                <a:latin typeface="Inter"/>
+                <a:ea typeface="Inter"/>
+                <a:cs typeface="Inter"/>
+                <a:sym typeface="Inter"/>
+              </a:rPr>
+              <a:t>rilevare</a:t>
+            </a:r>
+            <a:r>
+              <a:rPr lang="en-US" sz="1200" dirty="0">
+                <a:solidFill>
+                  <a:srgbClr val="94A3B8"/>
+                </a:solidFill>
+                <a:latin typeface="Inter"/>
+                <a:ea typeface="Inter"/>
+                <a:cs typeface="Inter"/>
+                <a:sym typeface="Inter"/>
+              </a:rPr>
+              <a:t> </a:t>
+            </a:r>
+            <a:r>
+              <a:rPr lang="en-US" sz="1200" dirty="0" err="1">
+                <a:solidFill>
+                  <a:srgbClr val="94A3B8"/>
+                </a:solidFill>
+                <a:latin typeface="Inter"/>
+                <a:ea typeface="Inter"/>
+                <a:cs typeface="Inter"/>
+                <a:sym typeface="Inter"/>
+              </a:rPr>
+              <a:t>l'ostacolo</a:t>
+            </a:r>
+            <a:r>
+              <a:rPr lang="en-US" sz="1200" dirty="0">
+                <a:solidFill>
+                  <a:srgbClr val="94A3B8"/>
+                </a:solidFill>
+                <a:latin typeface="Inter"/>
+                <a:ea typeface="Inter"/>
+                <a:cs typeface="Inter"/>
+                <a:sym typeface="Inter"/>
+              </a:rPr>
+              <a:t>.</a:t>
+            </a:r>
+          </a:p>
+          <a:p>
+            <a:pPr marL="457200" lvl="0" indent="-304800" algn="l" rtl="0">
+              <a:lnSpc>
+                <a:spcPct val="150000"/>
+              </a:lnSpc>
+              <a:spcBef>
+                <a:spcPts val="0"/>
+              </a:spcBef>
+              <a:spcAft>
+                <a:spcPts val="0"/>
+              </a:spcAft>
+              <a:buClr>
+                <a:srgbClr val="94A3B8"/>
+              </a:buClr>
+              <a:buSzPts val="1200"/>
+              <a:buChar char="●"/>
+            </a:pPr>
+            <a:r>
+              <a:rPr lang="en-US" sz="1200" dirty="0">
+                <a:solidFill>
+                  <a:srgbClr val="F8FAFC"/>
+                </a:solidFill>
+                <a:latin typeface="Inter SemiBold"/>
+                <a:ea typeface="Inter SemiBold"/>
+                <a:cs typeface="Inter SemiBold"/>
+                <a:sym typeface="Inter SemiBold"/>
+              </a:rPr>
+              <a:t>LED </a:t>
+            </a:r>
+            <a:r>
+              <a:rPr lang="en-US" sz="1200" dirty="0" err="1">
+                <a:solidFill>
+                  <a:srgbClr val="F8FAFC"/>
+                </a:solidFill>
+                <a:latin typeface="Inter SemiBold"/>
+                <a:ea typeface="Inter SemiBold"/>
+                <a:cs typeface="Inter SemiBold"/>
+                <a:sym typeface="Inter SemiBold"/>
+              </a:rPr>
+              <a:t>Fisico</a:t>
+            </a:r>
+            <a:r>
+              <a:rPr lang="en-US" sz="1200" dirty="0">
+                <a:solidFill>
+                  <a:srgbClr val="F8FAFC"/>
+                </a:solidFill>
+                <a:latin typeface="Inter SemiBold"/>
+                <a:ea typeface="Inter SemiBold"/>
+                <a:cs typeface="Inter SemiBold"/>
+                <a:sym typeface="Inter SemiBold"/>
+              </a:rPr>
+              <a:t>:</a:t>
+            </a:r>
+            <a:r>
+              <a:rPr lang="en-US" sz="1200" dirty="0">
+                <a:solidFill>
+                  <a:srgbClr val="94A3B8"/>
+                </a:solidFill>
+                <a:latin typeface="Inter"/>
+                <a:ea typeface="Inter"/>
+                <a:cs typeface="Inter"/>
+                <a:sym typeface="Inter"/>
+              </a:rPr>
+              <a:t> </a:t>
+            </a:r>
+            <a:r>
+              <a:rPr lang="en-US" sz="1200" dirty="0" err="1">
+                <a:solidFill>
+                  <a:srgbClr val="94A3B8"/>
+                </a:solidFill>
+                <a:latin typeface="Inter"/>
+                <a:ea typeface="Inter"/>
+                <a:cs typeface="Inter"/>
+                <a:sym typeface="Inter"/>
+              </a:rPr>
+              <a:t>Lampeggiante</a:t>
+            </a:r>
+            <a:r>
+              <a:rPr lang="en-US" sz="1200" dirty="0">
+                <a:solidFill>
+                  <a:srgbClr val="94A3B8"/>
+                </a:solidFill>
+                <a:latin typeface="Inter"/>
+                <a:ea typeface="Inter"/>
+                <a:cs typeface="Inter"/>
+                <a:sym typeface="Inter"/>
+              </a:rPr>
+              <a:t> in moto, </a:t>
+            </a:r>
+            <a:r>
+              <a:rPr lang="en-US" sz="1200" dirty="0" err="1">
+                <a:solidFill>
+                  <a:srgbClr val="94A3B8"/>
+                </a:solidFill>
+                <a:latin typeface="Inter"/>
+                <a:ea typeface="Inter"/>
+                <a:cs typeface="Inter"/>
+                <a:sym typeface="Inter"/>
+              </a:rPr>
+              <a:t>verde</a:t>
+            </a:r>
+            <a:r>
+              <a:rPr lang="en-US" sz="1200" dirty="0">
+                <a:solidFill>
+                  <a:srgbClr val="94A3B8"/>
+                </a:solidFill>
+                <a:latin typeface="Inter"/>
+                <a:ea typeface="Inter"/>
+                <a:cs typeface="Inter"/>
+                <a:sym typeface="Inter"/>
+              </a:rPr>
+              <a:t> </a:t>
+            </a:r>
+            <a:r>
+              <a:rPr lang="en-US" sz="1200" dirty="0" err="1">
+                <a:solidFill>
+                  <a:srgbClr val="94A3B8"/>
+                </a:solidFill>
+                <a:latin typeface="Inter"/>
+                <a:ea typeface="Inter"/>
+                <a:cs typeface="Inter"/>
+                <a:sym typeface="Inter"/>
+              </a:rPr>
+              <a:t>fisso</a:t>
+            </a:r>
+            <a:r>
+              <a:rPr lang="en-US" sz="1200" dirty="0">
+                <a:solidFill>
+                  <a:srgbClr val="94A3B8"/>
+                </a:solidFill>
+                <a:latin typeface="Inter"/>
+                <a:ea typeface="Inter"/>
+                <a:cs typeface="Inter"/>
+                <a:sym typeface="Inter"/>
+              </a:rPr>
+              <a:t> in </a:t>
+            </a:r>
+            <a:r>
+              <a:rPr lang="en-US" sz="1200" dirty="0" err="1">
+                <a:solidFill>
+                  <a:srgbClr val="94A3B8"/>
+                </a:solidFill>
+                <a:latin typeface="Inter"/>
+                <a:ea typeface="Inter"/>
+                <a:cs typeface="Inter"/>
+                <a:sym typeface="Inter"/>
+              </a:rPr>
+              <a:t>blocco</a:t>
+            </a:r>
+            <a:r>
+              <a:rPr lang="en-US" sz="1200">
+                <a:solidFill>
+                  <a:srgbClr val="94A3B8"/>
+                </a:solidFill>
+                <a:latin typeface="Inter"/>
+                <a:ea typeface="Inter"/>
+                <a:cs typeface="Inter"/>
+                <a:sym typeface="Inter"/>
+              </a:rPr>
+              <a:t>.</a:t>
+            </a:r>
+            <a:endParaRPr lang="en-US" dirty="0">
               <a:solidFill>
-                <a:srgbClr val="94A3B8"/>
+                <a:schemeClr val="dk1"/>
               </a:solidFill>
-              <a:latin typeface="Inter"/>
               <a:ea typeface="Inter"/>
-              <a:cs typeface="Inter"/>
-              <a:sym typeface="Inter"/>
             </a:endParaRPr>
           </a:p>
           <a:p>
@@ -21342,7 +21813,6 @@
                 <a:srgbClr val="94A3B8"/>
               </a:buClr>
               <a:buSzPts val="1200"/>
-              <a:buFont typeface="Inter"/>
               <a:buChar char="●"/>
             </a:pPr>
             <a:r>
@@ -21355,10 +21825,22 @@
                 <a:cs typeface="Inter SemiBold"/>
                 <a:sym typeface="Inter SemiBold"/>
               </a:rPr>
-              <a:t>LED Fisico:</a:t>
-            </a:r>
-            <a:r>
-              <a:rPr lang="en-US" sz="1200">
+              <a:t>MicroPython</a:t>
+            </a:r>
+            <a:r>
+              <a:rPr lang="en-US" sz="1200" dirty="0">
+                <a:solidFill>
+                  <a:srgbClr val="F8FAFC"/>
+                </a:solidFill>
+                <a:latin typeface="Inter SemiBold"/>
+                <a:ea typeface="Inter SemiBold"/>
+                <a:cs typeface="Inter SemiBold"/>
+                <a:sym typeface="Inter SemiBold"/>
+              </a:rPr>
+              <a:t>:</a:t>
+            </a:r>
+            <a:r>
+              <a:rPr lang="en-US" sz="1200" dirty="0">
                 <a:solidFill>
                   <a:srgbClr val="94A3B8"/>
                 </a:solidFill>
@@ -21367,46 +21849,10 @@
                 <a:cs typeface="Inter"/>
                 <a:sym typeface="Inter"/>
               </a:rPr>
-              <a:t> Lampeggiante in moto, verde fisso in blocco.</a:t>
-            </a:r>
-            <a:endParaRPr>
-              <a:solidFill>
-                <a:schemeClr val="dk1"/>
-              </a:solidFill>
-            </a:endParaRPr>
-          </a:p>
-          <a:p>
-            <a:pPr marL="457200" lvl="0" indent="-304800" algn="l" rtl="0">
-              <a:lnSpc>
-                <a:spcPct val="150000"/>
-              </a:lnSpc>
-              <a:spcBef>
-                <a:spcPts val="0"/>
-              </a:spcBef>
-              <a:spcAft>
-                <a:spcPts val="0"/>
-              </a:spcAft>
-              <a:buClr>
-                <a:srgbClr val="94A3B8"/>
-              </a:buClr>
-              <a:buSzPts val="1200"/>
-              <a:buFont typeface="Inter"/>
-              <a:buChar char="●"/>
-            </a:pPr>
-            <a:r>
-              <a:rPr lang="en-US" sz="1200">
-                <a:solidFill>
-                  <a:srgbClr val="F8FAFC"/>
-                </a:solidFill>
-                <a:latin typeface="Inter SemiBold"/>
-                <a:ea typeface="Inter SemiBold"/>
-                <a:cs typeface="Inter SemiBold"/>
-                <a:sym typeface="Inter SemiBold"/>
-              </a:rPr>
-              <a:t>MicroPython:</a:t>
-            </a:r>
-            <a:r>
-              <a:rPr lang="en-US" sz="1200">
+              <a:t> </a:t>
+            </a:r>
+            <a:r>
+              <a:rPr lang="en-US" sz="1200" dirty="0" err="1">
                 <a:solidFill>
                   <a:srgbClr val="94A3B8"/>
                 </a:solidFill>
@@ -21415,9 +21861,117 @@
                 <a:cs typeface="Inter"/>
                 <a:sym typeface="Inter"/>
               </a:rPr>
-              <a:t> Codice pulito e asincrono per l'invio distanze.</a:t>
-            </a:r>
-            <a:endParaRPr sz="1800">
+              <a:t>Codice</a:t>
+            </a:r>
+            <a:r>
+              <a:rPr lang="en-US" sz="1200" dirty="0">
+                <a:solidFill>
+                  <a:srgbClr val="94A3B8"/>
+                </a:solidFill>
+                <a:latin typeface="Inter"/>
+                <a:ea typeface="Inter"/>
+                <a:cs typeface="Inter"/>
+                <a:sym typeface="Inter"/>
+              </a:rPr>
+              <a:t> </a:t>
+            </a:r>
+            <a:r>
+              <a:rPr lang="en-US" sz="1200" dirty="0" err="1">
+                <a:solidFill>
+                  <a:srgbClr val="94A3B8"/>
+                </a:solidFill>
+                <a:latin typeface="Inter"/>
+                <a:ea typeface="Inter"/>
+                <a:cs typeface="Inter"/>
+                <a:sym typeface="Inter"/>
+              </a:rPr>
+              <a:t>pulito</a:t>
+            </a:r>
+            <a:r>
+              <a:rPr lang="en-US" sz="1200" dirty="0">
+                <a:solidFill>
+                  <a:srgbClr val="94A3B8"/>
+                </a:solidFill>
+                <a:latin typeface="Inter"/>
+                <a:ea typeface="Inter"/>
+                <a:cs typeface="Inter"/>
+                <a:sym typeface="Inter"/>
+              </a:rPr>
+              <a:t> e </a:t>
+            </a:r>
+            <a:r>
+              <a:rPr lang="en-US" sz="1200" dirty="0" err="1">
+                <a:solidFill>
+                  <a:srgbClr val="94A3B8"/>
+                </a:solidFill>
+                <a:latin typeface="Inter"/>
+                <a:ea typeface="Inter"/>
+                <a:cs typeface="Inter"/>
+                <a:sym typeface="Inter"/>
+              </a:rPr>
+              <a:t>asincrono</a:t>
+            </a:r>
+            <a:r>
+              <a:rPr lang="en-US" sz="1200" dirty="0">
+                <a:solidFill>
+                  <a:srgbClr val="94A3B8"/>
+                </a:solidFill>
+                <a:latin typeface="Inter"/>
+                <a:ea typeface="Inter"/>
+                <a:cs typeface="Inter"/>
+                <a:sym typeface="Inter"/>
+              </a:rPr>
+              <a:t> per </a:t>
+            </a:r>
+            <a:r>
+              <a:rPr lang="en-US" sz="1200" dirty="0" err="1">
+                <a:solidFill>
+                  <a:srgbClr val="94A3B8"/>
+                </a:solidFill>
+                <a:latin typeface="Inter"/>
+                <a:ea typeface="Inter"/>
+                <a:cs typeface="Inter"/>
+                <a:sym typeface="Inter"/>
+              </a:rPr>
+              <a:t>l'invio</a:t>
+            </a:r>
+            <a:r>
+              <a:rPr lang="en-US" sz="1200" dirty="0">
+                <a:solidFill>
+                  <a:srgbClr val="94A3B8"/>
+                </a:solidFill>
+                <a:latin typeface="Inter"/>
+                <a:ea typeface="Inter"/>
+                <a:cs typeface="Inter"/>
+                <a:sym typeface="Inter"/>
+              </a:rPr>
+              <a:t> </a:t>
+            </a:r>
+            <a:r>
+              <a:rPr lang="en-US" sz="1200" dirty="0" err="1">
+                <a:solidFill>
+                  <a:srgbClr val="94A3B8"/>
+                </a:solidFill>
+                <a:latin typeface="Inter"/>
+                <a:ea typeface="Inter"/>
+                <a:cs typeface="Inter"/>
+                <a:sym typeface="Inter"/>
+              </a:rPr>
+              <a:t>distanze</a:t>
+            </a:r>
+            <a:r>
+              <a:rPr lang="en-US" sz="1200" dirty="0">
+                <a:solidFill>
+                  <a:srgbClr val="94A3B8"/>
+                </a:solidFill>
+                <a:latin typeface="Inter"/>
+                <a:ea typeface="Inter"/>
+                <a:cs typeface="Inter"/>
+                <a:sym typeface="Inter"/>
+              </a:rPr>
+              <a:t>.</a:t>
+            </a:r>
+            <a:endParaRPr sz="1800" dirty="0">
               <a:solidFill>
                 <a:srgbClr val="F8FAFC"/>
               </a:solidFill>
@@ -21437,7 +21991,7 @@
               </a:spcAft>
               <a:buNone/>
             </a:pPr>
-            <a:endParaRPr sz="3200">
+            <a:endParaRPr sz="3200" dirty="0">
               <a:solidFill>
                 <a:schemeClr val="dk1"/>
               </a:solidFill>

</xml_diff>